<commit_message>
Arabic blank presentation: title-slide subtitle without the body bullet
Co-Authored-By: Claude Opus 5.5 <noreply@anthropic.com>
</commit_message>
<xml_diff>
--- a/web/templates/ar/new.pptx
+++ b/web/templates/ar/new.pptx
@@ -203,7 +203,12 @@
         </p:spPr>
         <p:txBody>
           <a:bodyPr/>
-          <a:lstStyle/>
+          <a:lstStyle>
+            <a:lvl1pPr marL="0" indent="0" algn="r" rtl="1">
+              <a:buNone/>
+              <a:defRPr sz="2400"/>
+            </a:lvl1pPr>
+          </a:lstStyle>
           <a:p>
             <a:pPr algn="r" rtl="1"/>
             <a:endParaRPr lang="ar-AE"/>

</xml_diff>